<commit_message>
update presentations and speaker notes
</commit_message>
<xml_diff>
--- a/presentations/dev-testing.pptx
+++ b/presentations/dev-testing.pptx
@@ -5887,8 +5887,8 @@
       </p:grpSpPr>
       <p:sp>
         <p:nvSpPr>
-          <p:cNvPr id="2" name="Text 0"/>
-          <p:cNvSpPr/>
+          <p:cNvPr id="2" name="TextBox 1"/>
+          <p:cNvSpPr txBox="1"/>
           <p:nvPr/>
         </p:nvSpPr>
         <p:spPr>
@@ -5900,652 +5900,803 @@
             <a:avLst/>
           </a:prstGeom>
           <a:noFill/>
-          <a:ln/>
-        </p:spPr>
-        <p:txBody>
-          <a:bodyPr wrap="square" lIns="0" tIns="0" rIns="0" bIns="0" rtlCol="0" anchor="ctr"/>
-          <a:lstStyle/>
-          <a:p>
-            <a:pPr indent="0" marL="0">
-              <a:buNone/>
-            </a:pPr>
-            <a:r>
-              <a:rPr lang="en-US" sz="3000" b="1" dirty="0">
+          <a:ln>
+            <a:noFill/>
+          </a:ln>
+        </p:spPr>
+        <p:txBody>
+          <a:bodyPr wrap="none">
+            <a:spAutoFit/>
+          </a:bodyPr>
+          <a:lstStyle/>
+          <a:p>
+            <a:pPr algn="l"/>
+            <a:r>
+              <a:rPr b="1" i="0" sz="2800">
                 <a:solidFill>
                   <a:srgbClr val="1E293B"/>
                 </a:solidFill>
-                <a:latin typeface="Cambria" pitchFamily="34" charset="0"/>
-                <a:ea typeface="Cambria" pitchFamily="34" charset="-122"/>
-                <a:cs typeface="Cambria" pitchFamily="34" charset="-120"/>
               </a:rPr>
               <a:t>The Testing Pyramid</a:t>
             </a:r>
-            <a:endParaRPr lang="en-US" sz="3000" dirty="0"/>
-          </a:p>
-        </p:txBody>
-      </p:sp>
-      <p:sp>
-        <p:nvSpPr>
-          <p:cNvPr id="3" name="Text 1"/>
-          <p:cNvSpPr/>
+          </a:p>
+        </p:txBody>
+      </p:sp>
+      <p:sp>
+        <p:nvSpPr>
+          <p:cNvPr id="3" name="TextBox 2"/>
+          <p:cNvSpPr txBox="1"/>
           <p:nvPr/>
         </p:nvSpPr>
         <p:spPr>
           <a:xfrm>
             <a:off x="457200" y="841248"/>
-            <a:ext cx="8229600" cy="320040"/>
-          </a:xfrm>
-          <a:prstGeom prst="rect">
-            <a:avLst/>
-          </a:prstGeom>
-          <a:noFill/>
-          <a:ln/>
-        </p:spPr>
-        <p:txBody>
-          <a:bodyPr wrap="square" lIns="0" tIns="0" rIns="0" bIns="0" rtlCol="0" anchor="ctr"/>
-          <a:lstStyle/>
-          <a:p>
-            <a:pPr indent="0" marL="0">
-              <a:buNone/>
-            </a:pPr>
-            <a:r>
-              <a:rPr lang="en-US" sz="1300" dirty="0">
+            <a:ext cx="8229600" cy="365760"/>
+          </a:xfrm>
+          <a:prstGeom prst="rect">
+            <a:avLst/>
+          </a:prstGeom>
+          <a:noFill/>
+          <a:ln>
+            <a:noFill/>
+          </a:ln>
+        </p:spPr>
+        <p:txBody>
+          <a:bodyPr wrap="none">
+            <a:spAutoFit/>
+          </a:bodyPr>
+          <a:lstStyle/>
+          <a:p>
+            <a:pPr algn="l"/>
+            <a:r>
+              <a:rPr b="0" i="0" sz="1300">
                 <a:solidFill>
                   <a:srgbClr val="5B6B7C"/>
                 </a:solidFill>
-                <a:latin typeface="Calibri" pitchFamily="34" charset="0"/>
-                <a:ea typeface="Calibri" pitchFamily="34" charset="-122"/>
-                <a:cs typeface="Calibri" pitchFamily="34" charset="-120"/>
-              </a:rPr>
-              <a:t>One picture that answers “how many of which tests?”</a:t>
-            </a:r>
-            <a:endParaRPr lang="en-US" sz="1300" dirty="0"/>
-          </a:p>
-        </p:txBody>
-      </p:sp>
-      <p:sp>
-        <p:nvSpPr>
-          <p:cNvPr id="4" name="Shape 2"/>
-          <p:cNvSpPr/>
-          <p:nvPr/>
-        </p:nvSpPr>
-        <p:spPr>
-          <a:xfrm>
-            <a:off x="2286000" y="1463040"/>
-            <a:ext cx="2103120" cy="841248"/>
-          </a:xfrm>
-          <a:prstGeom prst="roundRect">
-            <a:avLst>
-              <a:gd name="adj" fmla="val 7609"/>
-            </a:avLst>
+              </a:rPr>
+              <a:t>More tests at the bottom (fast · cheap · stable)  →  fewer at the top (slow · costly · brittle)</a:t>
+            </a:r>
+          </a:p>
+        </p:txBody>
+      </p:sp>
+      <p:sp>
+        <p:nvSpPr>
+          <p:cNvPr id="4" name="TextBox 3"/>
+          <p:cNvSpPr txBox="1"/>
+          <p:nvPr/>
+        </p:nvSpPr>
+        <p:spPr>
+          <a:xfrm>
+            <a:off x="2194560" y="1325880"/>
+            <a:ext cx="2286000" cy="1051560"/>
+          </a:xfrm>
+          <a:prstGeom prst="rect">
+            <a:avLst/>
           </a:prstGeom>
           <a:solidFill>
             <a:srgbClr val="14532D"/>
           </a:solidFill>
-          <a:ln/>
-        </p:spPr>
-      </p:sp>
-      <p:sp>
-        <p:nvSpPr>
-          <p:cNvPr id="5" name="Text 3"/>
-          <p:cNvSpPr/>
-          <p:nvPr/>
-        </p:nvSpPr>
-        <p:spPr>
-          <a:xfrm>
-            <a:off x="2286000" y="1463040"/>
-            <a:ext cx="2103120" cy="841248"/>
-          </a:xfrm>
-          <a:prstGeom prst="rect">
-            <a:avLst/>
-          </a:prstGeom>
-          <a:noFill/>
-          <a:ln/>
-        </p:spPr>
-        <p:txBody>
-          <a:bodyPr wrap="square" lIns="0" tIns="0" rIns="0" bIns="0" rtlCol="0" anchor="ctr"/>
-          <a:lstStyle/>
-          <a:p>
-            <a:pPr algn="ctr" indent="0" marL="0">
-              <a:buNone/>
-            </a:pPr>
-            <a:r>
-              <a:rPr lang="en-US" sz="1600" b="1" dirty="0">
+          <a:ln>
+            <a:noFill/>
+          </a:ln>
+        </p:spPr>
+        <p:txBody>
+          <a:bodyPr wrap="none">
+            <a:spAutoFit/>
+          </a:bodyPr>
+          <a:lstStyle/>
+          <a:p/>
+        </p:txBody>
+      </p:sp>
+      <p:sp>
+        <p:nvSpPr>
+          <p:cNvPr id="5" name="TextBox 4"/>
+          <p:cNvSpPr txBox="1"/>
+          <p:nvPr/>
+        </p:nvSpPr>
+        <p:spPr>
+          <a:xfrm>
+            <a:off x="2331720" y="1399032"/>
+            <a:ext cx="2103120" cy="960119"/>
+          </a:xfrm>
+          <a:prstGeom prst="rect">
+            <a:avLst/>
+          </a:prstGeom>
+          <a:noFill/>
+          <a:ln>
+            <a:noFill/>
+          </a:ln>
+        </p:spPr>
+        <p:txBody>
+          <a:bodyPr wrap="square">
+            <a:spAutoFit/>
+          </a:bodyPr>
+          <a:lstStyle/>
+          <a:p>
+            <a:pPr algn="l"/>
+            <a:r>
+              <a:rPr b="1" i="0" sz="1300">
                 <a:solidFill>
                   <a:srgbClr val="FFFFFF"/>
                 </a:solidFill>
-                <a:latin typeface="Calibri" pitchFamily="34" charset="0"/>
-                <a:ea typeface="Calibri" pitchFamily="34" charset="-122"/>
-                <a:cs typeface="Calibri" pitchFamily="34" charset="-120"/>
-              </a:rPr>
-              <a:t>E2E / UI  </a:t>
-            </a:r>
-            <a:pPr algn="ctr" indent="0" marL="0">
-              <a:buNone/>
-            </a:pPr>
-            <a:r>
-              <a:rPr lang="en-US" sz="1200" dirty="0">
+              </a:rPr>
+              <a:t>E2E / UI</a:t>
+            </a:r>
+            <a:r>
+              <a:rPr b="0" i="0" sz="1100">
                 <a:solidFill>
                   <a:srgbClr val="DCFCE7"/>
                 </a:solidFill>
-                <a:latin typeface="Calibri" pitchFamily="34" charset="0"/>
-                <a:ea typeface="Calibri" pitchFamily="34" charset="-122"/>
-                <a:cs typeface="Calibri" pitchFamily="34" charset="-120"/>
-              </a:rPr>
-              <a:t>(a few)</a:t>
-            </a:r>
-            <a:endParaRPr lang="en-US" sz="1600" dirty="0"/>
-          </a:p>
-        </p:txBody>
-      </p:sp>
-      <p:sp>
-        <p:nvSpPr>
-          <p:cNvPr id="6" name="Shape 4"/>
-          <p:cNvSpPr/>
-          <p:nvPr/>
-        </p:nvSpPr>
-        <p:spPr>
-          <a:xfrm>
-            <a:off x="1371600" y="2423160"/>
-            <a:ext cx="3931920" cy="841248"/>
-          </a:xfrm>
-          <a:prstGeom prst="roundRect">
-            <a:avLst>
-              <a:gd name="adj" fmla="val 7609"/>
-            </a:avLst>
+              </a:rPr>
+              <a:t>   —   a few</a:t>
+            </a:r>
+          </a:p>
+          <a:p>
+            <a:pPr algn="l"/>
+            <a:r>
+              <a:rPr b="0" i="0" sz="950">
+                <a:solidFill>
+                  <a:srgbClr val="DCFCE7"/>
+                </a:solidFill>
+              </a:rPr>
+              <a:t>Full user journeys through the real system</a:t>
+            </a:r>
+          </a:p>
+          <a:p>
+            <a:pPr algn="l"/>
+            <a:r>
+              <a:rPr b="0" i="1" sz="900">
+                <a:solidFill>
+                  <a:srgbClr val="A7F3D0"/>
+                </a:solidFill>
+              </a:rPr>
+              <a:t>Playwright  ·  Cypress  ·  Selenium</a:t>
+            </a:r>
+          </a:p>
+        </p:txBody>
+      </p:sp>
+      <p:sp>
+        <p:nvSpPr>
+          <p:cNvPr id="6" name="TextBox 5"/>
+          <p:cNvSpPr txBox="1"/>
+          <p:nvPr/>
+        </p:nvSpPr>
+        <p:spPr>
+          <a:xfrm>
+            <a:off x="1234440" y="2441447"/>
+            <a:ext cx="4206240" cy="1051560"/>
+          </a:xfrm>
+          <a:prstGeom prst="rect">
+            <a:avLst/>
           </a:prstGeom>
           <a:solidFill>
             <a:srgbClr val="15803D"/>
           </a:solidFill>
-          <a:ln/>
-        </p:spPr>
-      </p:sp>
-      <p:sp>
-        <p:nvSpPr>
-          <p:cNvPr id="7" name="Text 5"/>
-          <p:cNvSpPr/>
-          <p:nvPr/>
-        </p:nvSpPr>
-        <p:spPr>
-          <a:xfrm>
-            <a:off x="1371600" y="2423160"/>
-            <a:ext cx="3931920" cy="841248"/>
-          </a:xfrm>
-          <a:prstGeom prst="rect">
-            <a:avLst/>
-          </a:prstGeom>
-          <a:noFill/>
-          <a:ln/>
-        </p:spPr>
-        <p:txBody>
-          <a:bodyPr wrap="square" lIns="0" tIns="0" rIns="0" bIns="0" rtlCol="0" anchor="ctr"/>
-          <a:lstStyle/>
-          <a:p>
-            <a:pPr algn="ctr" indent="0" marL="0">
-              <a:buNone/>
-            </a:pPr>
-            <a:r>
-              <a:rPr lang="en-US" sz="1600" b="1" dirty="0">
+          <a:ln>
+            <a:noFill/>
+          </a:ln>
+        </p:spPr>
+        <p:txBody>
+          <a:bodyPr wrap="none">
+            <a:spAutoFit/>
+          </a:bodyPr>
+          <a:lstStyle/>
+          <a:p/>
+        </p:txBody>
+      </p:sp>
+      <p:sp>
+        <p:nvSpPr>
+          <p:cNvPr id="7" name="TextBox 6"/>
+          <p:cNvSpPr txBox="1"/>
+          <p:nvPr/>
+        </p:nvSpPr>
+        <p:spPr>
+          <a:xfrm>
+            <a:off x="1371600" y="2514599"/>
+            <a:ext cx="4023359" cy="960119"/>
+          </a:xfrm>
+          <a:prstGeom prst="rect">
+            <a:avLst/>
+          </a:prstGeom>
+          <a:noFill/>
+          <a:ln>
+            <a:noFill/>
+          </a:ln>
+        </p:spPr>
+        <p:txBody>
+          <a:bodyPr wrap="square">
+            <a:spAutoFit/>
+          </a:bodyPr>
+          <a:lstStyle/>
+          <a:p>
+            <a:pPr algn="l"/>
+            <a:r>
+              <a:rPr b="1" i="0" sz="1300">
                 <a:solidFill>
                   <a:srgbClr val="FFFFFF"/>
                 </a:solidFill>
-                <a:latin typeface="Calibri" pitchFamily="34" charset="0"/>
-                <a:ea typeface="Calibri" pitchFamily="34" charset="-122"/>
-                <a:cs typeface="Calibri" pitchFamily="34" charset="-120"/>
-              </a:rPr>
-              <a:t>Integration  </a:t>
-            </a:r>
-            <a:pPr algn="ctr" indent="0" marL="0">
-              <a:buNone/>
-            </a:pPr>
-            <a:r>
-              <a:rPr lang="en-US" sz="1200" dirty="0">
+              </a:rPr>
+              <a:t>Integration</a:t>
+            </a:r>
+            <a:r>
+              <a:rPr b="0" i="0" sz="1100">
                 <a:solidFill>
                   <a:srgbClr val="DCFCE7"/>
                 </a:solidFill>
-                <a:latin typeface="Calibri" pitchFamily="34" charset="0"/>
-                <a:ea typeface="Calibri" pitchFamily="34" charset="-122"/>
-                <a:cs typeface="Calibri" pitchFamily="34" charset="-120"/>
-              </a:rPr>
-              <a:t>(some)</a:t>
-            </a:r>
-            <a:endParaRPr lang="en-US" sz="1600" dirty="0"/>
-          </a:p>
-        </p:txBody>
-      </p:sp>
-      <p:sp>
-        <p:nvSpPr>
-          <p:cNvPr id="8" name="Shape 6"/>
-          <p:cNvSpPr/>
-          <p:nvPr/>
-        </p:nvSpPr>
-        <p:spPr>
-          <a:xfrm>
-            <a:off x="457200" y="3383280"/>
-            <a:ext cx="5760720" cy="841248"/>
-          </a:xfrm>
-          <a:prstGeom prst="roundRect">
-            <a:avLst>
-              <a:gd name="adj" fmla="val 7609"/>
-            </a:avLst>
+              </a:rPr>
+              <a:t>   —   some</a:t>
+            </a:r>
+          </a:p>
+          <a:p>
+            <a:pPr algn="l"/>
+            <a:r>
+              <a:rPr b="0" i="0" sz="950">
+                <a:solidFill>
+                  <a:srgbClr val="DCFCE7"/>
+                </a:solidFill>
+              </a:rPr>
+              <a:t>Modules talking to each other: API + DB, service calls</a:t>
+            </a:r>
+          </a:p>
+          <a:p>
+            <a:pPr algn="l"/>
+            <a:r>
+              <a:rPr b="0" i="1" sz="900">
+                <a:solidFill>
+                  <a:srgbClr val="A7F3D0"/>
+                </a:solidFill>
+              </a:rPr>
+              <a:t>Supertest  ·  TestContainers  ·  pytest + DB</a:t>
+            </a:r>
+          </a:p>
+        </p:txBody>
+      </p:sp>
+      <p:sp>
+        <p:nvSpPr>
+          <p:cNvPr id="8" name="TextBox 7"/>
+          <p:cNvSpPr txBox="1"/>
+          <p:nvPr/>
+        </p:nvSpPr>
+        <p:spPr>
+          <a:xfrm>
+            <a:off x="457200" y="3557015"/>
+            <a:ext cx="5760720" cy="1051560"/>
+          </a:xfrm>
+          <a:prstGeom prst="rect">
+            <a:avLst/>
           </a:prstGeom>
           <a:solidFill>
             <a:srgbClr val="22C55E"/>
           </a:solidFill>
-          <a:ln/>
-        </p:spPr>
-      </p:sp>
-      <p:sp>
-        <p:nvSpPr>
-          <p:cNvPr id="9" name="Text 7"/>
-          <p:cNvSpPr/>
-          <p:nvPr/>
-        </p:nvSpPr>
-        <p:spPr>
-          <a:xfrm>
-            <a:off x="457200" y="3383280"/>
-            <a:ext cx="5760720" cy="841248"/>
-          </a:xfrm>
-          <a:prstGeom prst="rect">
-            <a:avLst/>
-          </a:prstGeom>
-          <a:noFill/>
-          <a:ln/>
-        </p:spPr>
-        <p:txBody>
-          <a:bodyPr wrap="square" lIns="0" tIns="0" rIns="0" bIns="0" rtlCol="0" anchor="ctr"/>
-          <a:lstStyle/>
-          <a:p>
-            <a:pPr algn="ctr" indent="0" marL="0">
-              <a:buNone/>
-            </a:pPr>
-            <a:r>
-              <a:rPr lang="en-US" sz="1600" b="1" dirty="0">
+          <a:ln>
+            <a:noFill/>
+          </a:ln>
+        </p:spPr>
+        <p:txBody>
+          <a:bodyPr wrap="none">
+            <a:spAutoFit/>
+          </a:bodyPr>
+          <a:lstStyle/>
+          <a:p/>
+        </p:txBody>
+      </p:sp>
+      <p:sp>
+        <p:nvSpPr>
+          <p:cNvPr id="9" name="TextBox 8"/>
+          <p:cNvSpPr txBox="1"/>
+          <p:nvPr/>
+        </p:nvSpPr>
+        <p:spPr>
+          <a:xfrm>
+            <a:off x="594360" y="3630167"/>
+            <a:ext cx="5577840" cy="960119"/>
+          </a:xfrm>
+          <a:prstGeom prst="rect">
+            <a:avLst/>
+          </a:prstGeom>
+          <a:noFill/>
+          <a:ln>
+            <a:noFill/>
+          </a:ln>
+        </p:spPr>
+        <p:txBody>
+          <a:bodyPr wrap="square">
+            <a:spAutoFit/>
+          </a:bodyPr>
+          <a:lstStyle/>
+          <a:p>
+            <a:pPr algn="l"/>
+            <a:r>
+              <a:rPr b="1" i="0" sz="1300">
                 <a:solidFill>
                   <a:srgbClr val="FFFFFF"/>
                 </a:solidFill>
-                <a:latin typeface="Calibri" pitchFamily="34" charset="0"/>
-                <a:ea typeface="Calibri" pitchFamily="34" charset="-122"/>
-                <a:cs typeface="Calibri" pitchFamily="34" charset="-120"/>
-              </a:rPr>
-              <a:t>Unit  </a:t>
-            </a:r>
-            <a:pPr algn="ctr" indent="0" marL="0">
-              <a:buNone/>
-            </a:pPr>
-            <a:r>
-              <a:rPr lang="en-US" sz="1200" dirty="0">
-                <a:solidFill>
-                  <a:srgbClr val="DCFCE7"/>
-                </a:solidFill>
-                <a:latin typeface="Calibri" pitchFamily="34" charset="0"/>
-                <a:ea typeface="Calibri" pitchFamily="34" charset="-122"/>
-                <a:cs typeface="Calibri" pitchFamily="34" charset="-120"/>
-              </a:rPr>
-              <a:t>(lots)</a:t>
-            </a:r>
-            <a:endParaRPr lang="en-US" sz="1600" dirty="0"/>
-          </a:p>
-        </p:txBody>
-      </p:sp>
-      <p:sp>
-        <p:nvSpPr>
-          <p:cNvPr id="10" name="Text 8"/>
-          <p:cNvSpPr/>
-          <p:nvPr/>
-        </p:nvSpPr>
-        <p:spPr>
-          <a:xfrm>
-            <a:off x="457200" y="2103120"/>
-            <a:ext cx="914400" cy="1097280"/>
-          </a:xfrm>
-          <a:prstGeom prst="rect">
-            <a:avLst/>
-          </a:prstGeom>
-          <a:noFill/>
-          <a:ln/>
-        </p:spPr>
-        <p:txBody>
-          <a:bodyPr wrap="square" lIns="0" tIns="0" rIns="0" bIns="0" rtlCol="0" anchor="ctr"/>
-          <a:lstStyle/>
-          <a:p>
-            <a:pPr algn="ctr" indent="0" marL="0">
-              <a:buNone/>
-            </a:pPr>
-            <a:r>
-              <a:rPr lang="en-US" sz="1100" b="1" dirty="0">
-                <a:solidFill>
-                  <a:srgbClr val="15803D"/>
-                </a:solidFill>
-                <a:latin typeface="Calibri" pitchFamily="34" charset="0"/>
-                <a:ea typeface="Calibri" pitchFamily="34" charset="-122"/>
-                <a:cs typeface="Calibri" pitchFamily="34" charset="-120"/>
-              </a:rPr>
-              <a:t>Speed &amp;</a:t>
-            </a:r>
-            <a:endParaRPr lang="en-US" sz="1100" dirty="0"/>
-          </a:p>
-          <a:p>
-            <a:pPr algn="ctr" indent="0" marL="0">
-              <a:buNone/>
-            </a:pPr>
-            <a:r>
-              <a:rPr lang="en-US" sz="1100" b="1" dirty="0">
-                <a:solidFill>
-                  <a:srgbClr val="15803D"/>
-                </a:solidFill>
-                <a:latin typeface="Calibri" pitchFamily="34" charset="0"/>
-                <a:ea typeface="Calibri" pitchFamily="34" charset="-122"/>
-                <a:cs typeface="Calibri" pitchFamily="34" charset="-120"/>
-              </a:rPr>
-              <a:t>quantity ↓</a:t>
-            </a:r>
-            <a:endParaRPr lang="en-US" sz="1100" dirty="0"/>
-          </a:p>
-        </p:txBody>
-      </p:sp>
-      <p:sp>
-        <p:nvSpPr>
-          <p:cNvPr id="11" name="Text 9"/>
-          <p:cNvSpPr/>
-          <p:nvPr/>
-        </p:nvSpPr>
-        <p:spPr>
-          <a:xfrm>
-            <a:off x="5532120" y="1554480"/>
-            <a:ext cx="914400" cy="777240"/>
-          </a:xfrm>
-          <a:prstGeom prst="rect">
-            <a:avLst/>
-          </a:prstGeom>
-          <a:noFill/>
-          <a:ln/>
-        </p:spPr>
-        <p:txBody>
-          <a:bodyPr wrap="square" lIns="0" tIns="0" rIns="0" bIns="0" rtlCol="0" anchor="ctr"/>
-          <a:lstStyle/>
-          <a:p>
-            <a:pPr algn="ctr" indent="0" marL="0">
-              <a:buNone/>
-            </a:pPr>
-            <a:r>
-              <a:rPr lang="en-US" sz="1100" b="1" dirty="0">
+              </a:rPr>
+              <a:t>Unit</a:t>
+            </a:r>
+            <a:r>
+              <a:rPr b="0" i="0" sz="1100">
+                <a:solidFill>
+                  <a:srgbClr val="F0FDF4"/>
+                </a:solidFill>
+              </a:rPr>
+              <a:t>   —   lots</a:t>
+            </a:r>
+          </a:p>
+          <a:p>
+            <a:pPr algn="l"/>
+            <a:r>
+              <a:rPr b="0" i="0" sz="950">
+                <a:solidFill>
+                  <a:srgbClr val="F0FDF4"/>
+                </a:solidFill>
+              </a:rPr>
+              <a:t>One function or component tested in isolation</a:t>
+            </a:r>
+          </a:p>
+          <a:p>
+            <a:pPr algn="l"/>
+            <a:r>
+              <a:rPr b="0" i="1" sz="900">
+                <a:solidFill>
+                  <a:srgbClr val="F0FDF4"/>
+                </a:solidFill>
+              </a:rPr>
+              <a:t>Jest  ·  Vitest  ·  pytest  ·  JUnit</a:t>
+            </a:r>
+          </a:p>
+        </p:txBody>
+      </p:sp>
+      <p:sp>
+        <p:nvSpPr>
+          <p:cNvPr id="10" name="TextBox 9"/>
+          <p:cNvSpPr txBox="1"/>
+          <p:nvPr/>
+        </p:nvSpPr>
+        <p:spPr>
+          <a:xfrm>
+            <a:off x="457200" y="1371600"/>
+            <a:ext cx="1554480" cy="868680"/>
+          </a:xfrm>
+          <a:prstGeom prst="rect">
+            <a:avLst/>
+          </a:prstGeom>
+          <a:noFill/>
+          <a:ln>
+            <a:noFill/>
+          </a:ln>
+        </p:spPr>
+        <p:txBody>
+          <a:bodyPr wrap="square">
+            <a:spAutoFit/>
+          </a:bodyPr>
+          <a:lstStyle/>
+          <a:p>
+            <a:pPr algn="l"/>
+            <a:r>
+              <a:rPr b="1" i="0" sz="900">
                 <a:solidFill>
                   <a:srgbClr val="B91C1C"/>
                 </a:solidFill>
-                <a:latin typeface="Calibri" pitchFamily="34" charset="0"/>
-                <a:ea typeface="Calibri" pitchFamily="34" charset="-122"/>
-                <a:cs typeface="Calibri" pitchFamily="34" charset="-120"/>
-              </a:rPr>
-              <a:t>Cost &amp;</a:t>
-            </a:r>
-            <a:endParaRPr lang="en-US" sz="1100" dirty="0"/>
-          </a:p>
-          <a:p>
-            <a:pPr algn="ctr" indent="0" marL="0">
-              <a:buNone/>
-            </a:pPr>
-            <a:r>
-              <a:rPr lang="en-US" sz="1100" b="1" dirty="0">
+              </a:rPr>
+              <a:t>↑  going up:</a:t>
+            </a:r>
+          </a:p>
+          <a:p>
+            <a:pPr algn="l"/>
+            <a:r>
+              <a:rPr b="0" i="0" sz="850">
                 <a:solidFill>
                   <a:srgbClr val="B91C1C"/>
                 </a:solidFill>
-                <a:latin typeface="Calibri" pitchFamily="34" charset="0"/>
-                <a:ea typeface="Calibri" pitchFamily="34" charset="-122"/>
-                <a:cs typeface="Calibri" pitchFamily="34" charset="-120"/>
-              </a:rPr>
-              <a:t>fragility ↑</a:t>
-            </a:r>
-            <a:endParaRPr lang="en-US" sz="1100" dirty="0"/>
-          </a:p>
-        </p:txBody>
-      </p:sp>
-      <p:sp>
-        <p:nvSpPr>
-          <p:cNvPr id="12" name="Shape 10"/>
-          <p:cNvSpPr/>
-          <p:nvPr/>
-        </p:nvSpPr>
-        <p:spPr>
-          <a:xfrm>
-            <a:off x="7360920" y="1417320"/>
-            <a:ext cx="1371600" cy="9144"/>
-          </a:xfrm>
-          <a:prstGeom prst="roundRect">
-            <a:avLst/>
-          </a:prstGeom>
-          <a:solidFill>
-            <a:srgbClr val="FFFFFF"/>
-          </a:solidFill>
-          <a:ln/>
-        </p:spPr>
-      </p:sp>
-      <p:sp>
-        <p:nvSpPr>
-          <p:cNvPr id="13" name="Shape 11"/>
-          <p:cNvSpPr/>
-          <p:nvPr/>
-        </p:nvSpPr>
-        <p:spPr>
-          <a:xfrm>
-            <a:off x="6537960" y="1417320"/>
-            <a:ext cx="2194560" cy="3246120"/>
-          </a:xfrm>
-          <a:prstGeom prst="roundRect">
-            <a:avLst>
-              <a:gd name="adj" fmla="val 3333"/>
-            </a:avLst>
+              </a:rPr>
+              <a:t>fewer tests</a:t>
+            </a:r>
+          </a:p>
+          <a:p>
+            <a:pPr algn="l"/>
+            <a:r>
+              <a:rPr b="0" i="0" sz="850">
+                <a:solidFill>
+                  <a:srgbClr val="B91C1C"/>
+                </a:solidFill>
+              </a:rPr>
+              <a:t>slower to run</a:t>
+            </a:r>
+          </a:p>
+          <a:p>
+            <a:pPr algn="l"/>
+            <a:r>
+              <a:rPr b="0" i="0" sz="850">
+                <a:solidFill>
+                  <a:srgbClr val="B91C1C"/>
+                </a:solidFill>
+              </a:rPr>
+              <a:t>more costly</a:t>
+            </a:r>
+          </a:p>
+        </p:txBody>
+      </p:sp>
+      <p:sp>
+        <p:nvSpPr>
+          <p:cNvPr id="11" name="TextBox 10"/>
+          <p:cNvSpPr txBox="1"/>
+          <p:nvPr/>
+        </p:nvSpPr>
+        <p:spPr>
+          <a:xfrm>
+            <a:off x="6537960" y="1325880"/>
+            <a:ext cx="2240280" cy="3291840"/>
+          </a:xfrm>
+          <a:prstGeom prst="rect">
+            <a:avLst/>
           </a:prstGeom>
           <a:solidFill>
             <a:srgbClr val="F0FDF4"/>
           </a:solidFill>
-          <a:ln w="12700">
-            <a:solidFill>
-              <a:srgbClr val="D7EBDD"/>
-            </a:solidFill>
-            <a:prstDash val="solid"/>
+          <a:ln>
+            <a:noFill/>
           </a:ln>
         </p:spPr>
-      </p:sp>
-      <p:sp>
-        <p:nvSpPr>
-          <p:cNvPr id="14" name="Text 12"/>
-          <p:cNvSpPr/>
-          <p:nvPr/>
-        </p:nvSpPr>
-        <p:spPr>
-          <a:xfrm>
-            <a:off x="6720840" y="1572768"/>
-            <a:ext cx="1828800" cy="292608"/>
-          </a:xfrm>
-          <a:prstGeom prst="rect">
-            <a:avLst/>
-          </a:prstGeom>
-          <a:noFill/>
-          <a:ln/>
-        </p:spPr>
-        <p:txBody>
-          <a:bodyPr wrap="square" lIns="0" tIns="0" rIns="0" bIns="0" rtlCol="0" anchor="ctr"/>
-          <a:lstStyle/>
-          <a:p>
-            <a:pPr indent="0" marL="0">
-              <a:buNone/>
-            </a:pPr>
-            <a:r>
-              <a:rPr lang="en-US" sz="1300" b="1" dirty="0">
+        <p:txBody>
+          <a:bodyPr wrap="none">
+            <a:spAutoFit/>
+          </a:bodyPr>
+          <a:lstStyle/>
+          <a:p/>
+        </p:txBody>
+      </p:sp>
+      <p:sp>
+        <p:nvSpPr>
+          <p:cNvPr id="12" name="TextBox 11"/>
+          <p:cNvSpPr txBox="1"/>
+          <p:nvPr/>
+        </p:nvSpPr>
+        <p:spPr>
+          <a:xfrm>
+            <a:off x="6675120" y="1463039"/>
+            <a:ext cx="2011680" cy="320040"/>
+          </a:xfrm>
+          <a:prstGeom prst="rect">
+            <a:avLst/>
+          </a:prstGeom>
+          <a:noFill/>
+          <a:ln>
+            <a:noFill/>
+          </a:ln>
+        </p:spPr>
+        <p:txBody>
+          <a:bodyPr wrap="none">
+            <a:spAutoFit/>
+          </a:bodyPr>
+          <a:lstStyle/>
+          <a:p>
+            <a:pPr algn="l"/>
+            <a:r>
+              <a:rPr b="1" i="0" sz="1200">
                 <a:solidFill>
                   <a:srgbClr val="14532D"/>
                 </a:solidFill>
-                <a:latin typeface="Calibri" pitchFamily="34" charset="0"/>
-                <a:ea typeface="Calibri" pitchFamily="34" charset="-122"/>
-                <a:cs typeface="Calibri" pitchFamily="34" charset="-120"/>
               </a:rPr>
               <a:t>Rule of thumb</a:t>
             </a:r>
-            <a:endParaRPr lang="en-US" sz="1300" dirty="0"/>
-          </a:p>
-        </p:txBody>
-      </p:sp>
-      <p:sp>
-        <p:nvSpPr>
-          <p:cNvPr id="15" name="Text 13"/>
-          <p:cNvSpPr/>
-          <p:nvPr/>
-        </p:nvSpPr>
-        <p:spPr>
-          <a:xfrm>
-            <a:off x="6720840" y="1920240"/>
-            <a:ext cx="1828800" cy="2103120"/>
-          </a:xfrm>
-          <a:prstGeom prst="rect">
-            <a:avLst/>
-          </a:prstGeom>
-          <a:noFill/>
-          <a:ln/>
-        </p:spPr>
-        <p:txBody>
-          <a:bodyPr wrap="square" lIns="0" tIns="0" rIns="0" bIns="0" rtlCol="0" anchor="ctr"/>
-          <a:lstStyle/>
-          <a:p>
-            <a:pPr indent="0" marL="0">
-              <a:buNone/>
-            </a:pPr>
-            <a:r>
-              <a:rPr lang="en-US" sz="1300" b="1" dirty="0">
+          </a:p>
+        </p:txBody>
+      </p:sp>
+      <p:sp>
+        <p:nvSpPr>
+          <p:cNvPr id="13" name="TextBox 12"/>
+          <p:cNvSpPr txBox="1"/>
+          <p:nvPr/>
+        </p:nvSpPr>
+        <p:spPr>
+          <a:xfrm>
+            <a:off x="6675120" y="1828800"/>
+            <a:ext cx="2011680" cy="347472"/>
+          </a:xfrm>
+          <a:prstGeom prst="rect">
+            <a:avLst/>
+          </a:prstGeom>
+          <a:noFill/>
+          <a:ln>
+            <a:noFill/>
+          </a:ln>
+        </p:spPr>
+        <p:txBody>
+          <a:bodyPr wrap="none">
+            <a:spAutoFit/>
+          </a:bodyPr>
+          <a:lstStyle/>
+          <a:p>
+            <a:pPr algn="l"/>
+            <a:r>
+              <a:rPr b="1" i="0" sz="2000">
                 <a:solidFill>
                   <a:srgbClr val="15803D"/>
                 </a:solidFill>
-                <a:latin typeface="Calibri" pitchFamily="34" charset="0"/>
-                <a:ea typeface="Calibri" pitchFamily="34" charset="-122"/>
-                <a:cs typeface="Calibri" pitchFamily="34" charset="-120"/>
               </a:rPr>
               <a:t>~70%</a:t>
             </a:r>
-            <a:endParaRPr lang="en-US" sz="1300" dirty="0"/>
-          </a:p>
-          <a:p>
-            <a:pPr indent="0" marL="0">
-              <a:buNone/>
-            </a:pPr>
-            <a:r>
-              <a:rPr lang="en-US" sz="1300" dirty="0">
+          </a:p>
+        </p:txBody>
+      </p:sp>
+      <p:sp>
+        <p:nvSpPr>
+          <p:cNvPr id="14" name="TextBox 13"/>
+          <p:cNvSpPr txBox="1"/>
+          <p:nvPr/>
+        </p:nvSpPr>
+        <p:spPr>
+          <a:xfrm>
+            <a:off x="6675120" y="2139696"/>
+            <a:ext cx="2011680" cy="256032"/>
+          </a:xfrm>
+          <a:prstGeom prst="rect">
+            <a:avLst/>
+          </a:prstGeom>
+          <a:noFill/>
+          <a:ln>
+            <a:noFill/>
+          </a:ln>
+        </p:spPr>
+        <p:txBody>
+          <a:bodyPr wrap="none">
+            <a:spAutoFit/>
+          </a:bodyPr>
+          <a:lstStyle/>
+          <a:p>
+            <a:pPr algn="l"/>
+            <a:r>
+              <a:rPr b="0" i="0" sz="1000">
                 <a:solidFill>
                   <a:srgbClr val="5B6B7C"/>
                 </a:solidFill>
-                <a:latin typeface="Calibri" pitchFamily="34" charset="0"/>
-                <a:ea typeface="Calibri" pitchFamily="34" charset="-122"/>
-                <a:cs typeface="Calibri" pitchFamily="34" charset="-120"/>
-              </a:rPr>
-              <a:t>unit</a:t>
-            </a:r>
-            <a:endParaRPr lang="en-US" sz="1300" dirty="0"/>
-          </a:p>
-          <a:p>
-            <a:pPr indent="0" marL="0">
-              <a:buNone/>
-            </a:pPr>
-            <a:r>
-              <a:rPr lang="en-US" sz="1300" b="1" dirty="0">
+              </a:rPr>
+              <a:t>Unit tests</a:t>
+            </a:r>
+          </a:p>
+        </p:txBody>
+      </p:sp>
+      <p:sp>
+        <p:nvSpPr>
+          <p:cNvPr id="15" name="TextBox 14"/>
+          <p:cNvSpPr txBox="1"/>
+          <p:nvPr/>
+        </p:nvSpPr>
+        <p:spPr>
+          <a:xfrm>
+            <a:off x="6675120" y="2441448"/>
+            <a:ext cx="1965960" cy="18288"/>
+          </a:xfrm>
+          <a:prstGeom prst="rect">
+            <a:avLst/>
+          </a:prstGeom>
+          <a:solidFill>
+            <a:srgbClr val="D1FAE5"/>
+          </a:solidFill>
+          <a:ln>
+            <a:noFill/>
+          </a:ln>
+        </p:spPr>
+        <p:txBody>
+          <a:bodyPr wrap="none">
+            <a:spAutoFit/>
+          </a:bodyPr>
+          <a:lstStyle/>
+          <a:p/>
+        </p:txBody>
+      </p:sp>
+      <p:sp>
+        <p:nvSpPr>
+          <p:cNvPr id="16" name="TextBox 15"/>
+          <p:cNvSpPr txBox="1"/>
+          <p:nvPr/>
+        </p:nvSpPr>
+        <p:spPr>
+          <a:xfrm>
+            <a:off x="6675120" y="2514600"/>
+            <a:ext cx="2011680" cy="347472"/>
+          </a:xfrm>
+          <a:prstGeom prst="rect">
+            <a:avLst/>
+          </a:prstGeom>
+          <a:noFill/>
+          <a:ln>
+            <a:noFill/>
+          </a:ln>
+        </p:spPr>
+        <p:txBody>
+          <a:bodyPr wrap="none">
+            <a:spAutoFit/>
+          </a:bodyPr>
+          <a:lstStyle/>
+          <a:p>
+            <a:pPr algn="l"/>
+            <a:r>
+              <a:rPr b="1" i="0" sz="2000">
                 <a:solidFill>
                   <a:srgbClr val="15803D"/>
                 </a:solidFill>
-                <a:latin typeface="Calibri" pitchFamily="34" charset="0"/>
-                <a:ea typeface="Calibri" pitchFamily="34" charset="-122"/>
-                <a:cs typeface="Calibri" pitchFamily="34" charset="-120"/>
               </a:rPr>
               <a:t>~20%</a:t>
             </a:r>
-            <a:endParaRPr lang="en-US" sz="1300" dirty="0"/>
-          </a:p>
-          <a:p>
-            <a:pPr indent="0" marL="0">
-              <a:buNone/>
-            </a:pPr>
-            <a:r>
-              <a:rPr lang="en-US" sz="1300" dirty="0">
+          </a:p>
+        </p:txBody>
+      </p:sp>
+      <p:sp>
+        <p:nvSpPr>
+          <p:cNvPr id="17" name="TextBox 16"/>
+          <p:cNvSpPr txBox="1"/>
+          <p:nvPr/>
+        </p:nvSpPr>
+        <p:spPr>
+          <a:xfrm>
+            <a:off x="6675120" y="2825496"/>
+            <a:ext cx="2011680" cy="256032"/>
+          </a:xfrm>
+          <a:prstGeom prst="rect">
+            <a:avLst/>
+          </a:prstGeom>
+          <a:noFill/>
+          <a:ln>
+            <a:noFill/>
+          </a:ln>
+        </p:spPr>
+        <p:txBody>
+          <a:bodyPr wrap="none">
+            <a:spAutoFit/>
+          </a:bodyPr>
+          <a:lstStyle/>
+          <a:p>
+            <a:pPr algn="l"/>
+            <a:r>
+              <a:rPr b="0" i="0" sz="1000">
                 <a:solidFill>
                   <a:srgbClr val="5B6B7C"/>
                 </a:solidFill>
-                <a:latin typeface="Calibri" pitchFamily="34" charset="0"/>
-                <a:ea typeface="Calibri" pitchFamily="34" charset="-122"/>
-                <a:cs typeface="Calibri" pitchFamily="34" charset="-120"/>
-              </a:rPr>
-              <a:t>integration</a:t>
-            </a:r>
-            <a:endParaRPr lang="en-US" sz="1300" dirty="0"/>
-          </a:p>
-          <a:p>
-            <a:pPr indent="0" marL="0">
-              <a:buNone/>
-            </a:pPr>
-            <a:r>
-              <a:rPr lang="en-US" sz="1300" b="1" dirty="0">
+              </a:rPr>
+              <a:t>Integration</a:t>
+            </a:r>
+          </a:p>
+        </p:txBody>
+      </p:sp>
+      <p:sp>
+        <p:nvSpPr>
+          <p:cNvPr id="18" name="TextBox 17"/>
+          <p:cNvSpPr txBox="1"/>
+          <p:nvPr/>
+        </p:nvSpPr>
+        <p:spPr>
+          <a:xfrm>
+            <a:off x="6675120" y="3127248"/>
+            <a:ext cx="1965960" cy="18288"/>
+          </a:xfrm>
+          <a:prstGeom prst="rect">
+            <a:avLst/>
+          </a:prstGeom>
+          <a:solidFill>
+            <a:srgbClr val="D1FAE5"/>
+          </a:solidFill>
+          <a:ln>
+            <a:noFill/>
+          </a:ln>
+        </p:spPr>
+        <p:txBody>
+          <a:bodyPr wrap="none">
+            <a:spAutoFit/>
+          </a:bodyPr>
+          <a:lstStyle/>
+          <a:p/>
+        </p:txBody>
+      </p:sp>
+      <p:sp>
+        <p:nvSpPr>
+          <p:cNvPr id="19" name="TextBox 18"/>
+          <p:cNvSpPr txBox="1"/>
+          <p:nvPr/>
+        </p:nvSpPr>
+        <p:spPr>
+          <a:xfrm>
+            <a:off x="6675120" y="3200400"/>
+            <a:ext cx="2011680" cy="347472"/>
+          </a:xfrm>
+          <a:prstGeom prst="rect">
+            <a:avLst/>
+          </a:prstGeom>
+          <a:noFill/>
+          <a:ln>
+            <a:noFill/>
+          </a:ln>
+        </p:spPr>
+        <p:txBody>
+          <a:bodyPr wrap="none">
+            <a:spAutoFit/>
+          </a:bodyPr>
+          <a:lstStyle/>
+          <a:p>
+            <a:pPr algn="l"/>
+            <a:r>
+              <a:rPr b="1" i="0" sz="2000">
                 <a:solidFill>
                   <a:srgbClr val="15803D"/>
                 </a:solidFill>
-                <a:latin typeface="Calibri" pitchFamily="34" charset="0"/>
-                <a:ea typeface="Calibri" pitchFamily="34" charset="-122"/>
-                <a:cs typeface="Calibri" pitchFamily="34" charset="-120"/>
               </a:rPr>
               <a:t>~10%</a:t>
             </a:r>
-            <a:endParaRPr lang="en-US" sz="1300" dirty="0"/>
-          </a:p>
-          <a:p>
-            <a:pPr indent="0" marL="0">
-              <a:buNone/>
-            </a:pPr>
-            <a:r>
-              <a:rPr lang="en-US" sz="1300" dirty="0">
+          </a:p>
+        </p:txBody>
+      </p:sp>
+      <p:sp>
+        <p:nvSpPr>
+          <p:cNvPr id="20" name="TextBox 19"/>
+          <p:cNvSpPr txBox="1"/>
+          <p:nvPr/>
+        </p:nvSpPr>
+        <p:spPr>
+          <a:xfrm>
+            <a:off x="6675120" y="3511296"/>
+            <a:ext cx="2011680" cy="256032"/>
+          </a:xfrm>
+          <a:prstGeom prst="rect">
+            <a:avLst/>
+          </a:prstGeom>
+          <a:noFill/>
+          <a:ln>
+            <a:noFill/>
+          </a:ln>
+        </p:spPr>
+        <p:txBody>
+          <a:bodyPr wrap="none">
+            <a:spAutoFit/>
+          </a:bodyPr>
+          <a:lstStyle/>
+          <a:p>
+            <a:pPr algn="l"/>
+            <a:r>
+              <a:rPr b="0" i="0" sz="1000">
                 <a:solidFill>
                   <a:srgbClr val="5B6B7C"/>
                 </a:solidFill>
-                <a:latin typeface="Calibri" pitchFamily="34" charset="0"/>
-                <a:ea typeface="Calibri" pitchFamily="34" charset="-122"/>
-                <a:cs typeface="Calibri" pitchFamily="34" charset="-120"/>
               </a:rPr>
               <a:t>E2E</a:t>
             </a:r>
-            <a:endParaRPr lang="en-US" sz="1300" dirty="0"/>
-          </a:p>
-        </p:txBody>
-      </p:sp>
-      <p:sp>
-        <p:nvSpPr>
-          <p:cNvPr id="16" name="Text 14"/>
-          <p:cNvSpPr/>
-          <p:nvPr/>
-        </p:nvSpPr>
-        <p:spPr>
-          <a:xfrm>
-            <a:off x="6720840" y="4069080"/>
-            <a:ext cx="1874520" cy="548640"/>
-          </a:xfrm>
-          <a:prstGeom prst="rect">
-            <a:avLst/>
-          </a:prstGeom>
-          <a:noFill/>
-          <a:ln/>
-        </p:spPr>
-        <p:txBody>
-          <a:bodyPr wrap="square" lIns="0" tIns="0" rIns="0" bIns="0" rtlCol="0" anchor="ctr"/>
-          <a:lstStyle/>
-          <a:p>
-            <a:pPr indent="0" marL="0">
-              <a:buNone/>
-            </a:pPr>
-            <a:r>
-              <a:rPr lang="en-US" sz="1050" i="1" dirty="0">
+          </a:p>
+        </p:txBody>
+      </p:sp>
+      <p:sp>
+        <p:nvSpPr>
+          <p:cNvPr id="21" name="TextBox 20"/>
+          <p:cNvSpPr txBox="1"/>
+          <p:nvPr/>
+        </p:nvSpPr>
+        <p:spPr>
+          <a:xfrm>
+            <a:off x="6629400" y="4114800"/>
+            <a:ext cx="2103120" cy="457200"/>
+          </a:xfrm>
+          <a:prstGeom prst="rect">
+            <a:avLst/>
+          </a:prstGeom>
+          <a:noFill/>
+          <a:ln>
+            <a:noFill/>
+          </a:ln>
+        </p:spPr>
+        <p:txBody>
+          <a:bodyPr wrap="square">
+            <a:spAutoFit/>
+          </a:bodyPr>
+          <a:lstStyle/>
+          <a:p>
+            <a:pPr algn="l"/>
+            <a:r>
+              <a:rPr b="0" i="1" sz="900">
                 <a:solidFill>
                   <a:srgbClr val="5B6B7C"/>
                 </a:solidFill>
-                <a:latin typeface="Calibri" pitchFamily="34" charset="0"/>
-                <a:ea typeface="Calibri" pitchFamily="34" charset="-122"/>
-                <a:cs typeface="Calibri" pitchFamily="34" charset="-120"/>
               </a:rPr>
               <a:t>A guide, not a law — adjust per project.</a:t>
             </a:r>
-            <a:endParaRPr lang="en-US" sz="1050" dirty="0"/>
           </a:p>
         </p:txBody>
       </p:sp>

</xml_diff>